<commit_message>
finish test phase 1 data using different model and approach
</commit_message>
<xml_diff>
--- a/Final_workflow.pptx
+++ b/Final_workflow.pptx
@@ -137,6 +137,11 @@
       </a:defRPr>
     </a:lvl9pPr>
   </p:defaultTextStyle>
+  <p:extLst>
+    <p:ext uri="{EFAFB233-063F-42B5-8137-9DF3F51BA10A}">
+      <p15:sldGuideLst xmlns:p15="http://schemas.microsoft.com/office/powerpoint/2012/main"/>
+    </p:ext>
+  </p:extLst>
 </p:presentation>
 </file>
 
@@ -7032,7 +7037,7 @@
           <a:p>
             <a:fld id="{B91EF44D-EE28-F64D-96D8-55EF481E7992}" type="datetimeFigureOut">
               <a:rPr lang="en-US" smtClean="0"/>
-              <a:t>12/19/25</a:t>
+              <a:t>3/16/26</a:t>
             </a:fld>
             <a:endParaRPr lang="en-US"/>
           </a:p>
@@ -7230,7 +7235,7 @@
           <a:p>
             <a:fld id="{B91EF44D-EE28-F64D-96D8-55EF481E7992}" type="datetimeFigureOut">
               <a:rPr lang="en-US" smtClean="0"/>
-              <a:t>12/19/25</a:t>
+              <a:t>3/16/26</a:t>
             </a:fld>
             <a:endParaRPr lang="en-US"/>
           </a:p>
@@ -7438,7 +7443,7 @@
           <a:p>
             <a:fld id="{B91EF44D-EE28-F64D-96D8-55EF481E7992}" type="datetimeFigureOut">
               <a:rPr lang="en-US" smtClean="0"/>
-              <a:t>12/19/25</a:t>
+              <a:t>3/16/26</a:t>
             </a:fld>
             <a:endParaRPr lang="en-US"/>
           </a:p>
@@ -7636,7 +7641,7 @@
           <a:p>
             <a:fld id="{B91EF44D-EE28-F64D-96D8-55EF481E7992}" type="datetimeFigureOut">
               <a:rPr lang="en-US" smtClean="0"/>
-              <a:t>12/19/25</a:t>
+              <a:t>3/16/26</a:t>
             </a:fld>
             <a:endParaRPr lang="en-US"/>
           </a:p>
@@ -7911,7 +7916,7 @@
           <a:p>
             <a:fld id="{B91EF44D-EE28-F64D-96D8-55EF481E7992}" type="datetimeFigureOut">
               <a:rPr lang="en-US" smtClean="0"/>
-              <a:t>12/19/25</a:t>
+              <a:t>3/16/26</a:t>
             </a:fld>
             <a:endParaRPr lang="en-US"/>
           </a:p>
@@ -8176,7 +8181,7 @@
           <a:p>
             <a:fld id="{B91EF44D-EE28-F64D-96D8-55EF481E7992}" type="datetimeFigureOut">
               <a:rPr lang="en-US" smtClean="0"/>
-              <a:t>12/19/25</a:t>
+              <a:t>3/16/26</a:t>
             </a:fld>
             <a:endParaRPr lang="en-US"/>
           </a:p>
@@ -8588,7 +8593,7 @@
           <a:p>
             <a:fld id="{B91EF44D-EE28-F64D-96D8-55EF481E7992}" type="datetimeFigureOut">
               <a:rPr lang="en-US" smtClean="0"/>
-              <a:t>12/19/25</a:t>
+              <a:t>3/16/26</a:t>
             </a:fld>
             <a:endParaRPr lang="en-US"/>
           </a:p>
@@ -8729,7 +8734,7 @@
           <a:p>
             <a:fld id="{B91EF44D-EE28-F64D-96D8-55EF481E7992}" type="datetimeFigureOut">
               <a:rPr lang="en-US" smtClean="0"/>
-              <a:t>12/19/25</a:t>
+              <a:t>3/16/26</a:t>
             </a:fld>
             <a:endParaRPr lang="en-US"/>
           </a:p>
@@ -8842,7 +8847,7 @@
           <a:p>
             <a:fld id="{B91EF44D-EE28-F64D-96D8-55EF481E7992}" type="datetimeFigureOut">
               <a:rPr lang="en-US" smtClean="0"/>
-              <a:t>12/19/25</a:t>
+              <a:t>3/16/26</a:t>
             </a:fld>
             <a:endParaRPr lang="en-US"/>
           </a:p>
@@ -9153,7 +9158,7 @@
           <a:p>
             <a:fld id="{B91EF44D-EE28-F64D-96D8-55EF481E7992}" type="datetimeFigureOut">
               <a:rPr lang="en-US" smtClean="0"/>
-              <a:t>12/19/25</a:t>
+              <a:t>3/16/26</a:t>
             </a:fld>
             <a:endParaRPr lang="en-US"/>
           </a:p>
@@ -9441,7 +9446,7 @@
           <a:p>
             <a:fld id="{B91EF44D-EE28-F64D-96D8-55EF481E7992}" type="datetimeFigureOut">
               <a:rPr lang="en-US" smtClean="0"/>
-              <a:t>12/19/25</a:t>
+              <a:t>3/16/26</a:t>
             </a:fld>
             <a:endParaRPr lang="en-US"/>
           </a:p>
@@ -9682,7 +9687,7 @@
           <a:p>
             <a:fld id="{B91EF44D-EE28-F64D-96D8-55EF481E7992}" type="datetimeFigureOut">
               <a:rPr lang="en-US" smtClean="0"/>
-              <a:t>12/19/25</a:t>
+              <a:t>3/16/26</a:t>
             </a:fld>
             <a:endParaRPr lang="en-US"/>
           </a:p>
@@ -18572,7 +18577,7 @@
             <p:ph idx="1"/>
             <p:extLst>
               <p:ext uri="{D42A27DB-BD31-4B8C-83A1-F6EECF244321}">
-                <p14:modId xmlns:p14="http://schemas.microsoft.com/office/powerpoint/2010/main" val="3746518181"/>
+                <p14:modId xmlns:p14="http://schemas.microsoft.com/office/powerpoint/2010/main" val="1431846572"/>
               </p:ext>
             </p:extLst>
           </p:nvPr>
@@ -18785,7 +18790,10 @@
                     <a:bodyPr/>
                     <a:lstStyle/>
                     <a:p>
-                      <a:endParaRPr lang="en-US" dirty="0"/>
+                      <a:r>
+                        <a:rPr lang="en-US" dirty="0"/>
+                        <a:t>82.8</a:t>
+                      </a:r>
                     </a:p>
                   </a:txBody>
                   <a:tcPr/>
@@ -18795,7 +18803,10 @@
                     <a:bodyPr/>
                     <a:lstStyle/>
                     <a:p>
-                      <a:endParaRPr lang="en-US" dirty="0"/>
+                      <a:r>
+                        <a:rPr lang="en-US" dirty="0"/>
+                        <a:t>66.8</a:t>
+                      </a:r>
                     </a:p>
                   </a:txBody>
                   <a:tcPr/>
@@ -18805,7 +18816,10 @@
                     <a:bodyPr/>
                     <a:lstStyle/>
                     <a:p>
-                      <a:endParaRPr lang="en-US" dirty="0"/>
+                      <a:r>
+                        <a:rPr lang="en-US" dirty="0"/>
+                        <a:t>70.0</a:t>
+                      </a:r>
                     </a:p>
                   </a:txBody>
                   <a:tcPr/>
@@ -18815,7 +18829,10 @@
                     <a:bodyPr/>
                     <a:lstStyle/>
                     <a:p>
-                      <a:endParaRPr lang="en-US" dirty="0"/>
+                      <a:r>
+                        <a:rPr lang="en-US" dirty="0"/>
+                        <a:t>19.10min</a:t>
+                      </a:r>
                     </a:p>
                   </a:txBody>
                   <a:tcPr/>
@@ -18825,7 +18842,10 @@
                     <a:bodyPr/>
                     <a:lstStyle/>
                     <a:p>
-                      <a:endParaRPr lang="en-US" dirty="0"/>
+                      <a:r>
+                        <a:rPr lang="en-US" dirty="0"/>
+                        <a:t>1.36</a:t>
+                      </a:r>
                     </a:p>
                   </a:txBody>
                   <a:tcPr/>
@@ -18902,7 +18922,10 @@
                     <a:bodyPr/>
                     <a:lstStyle/>
                     <a:p>
-                      <a:endParaRPr lang="en-US" dirty="0"/>
+                      <a:r>
+                        <a:rPr lang="en-US" dirty="0"/>
+                        <a:t>92.5</a:t>
+                      </a:r>
                     </a:p>
                   </a:txBody>
                   <a:tcPr/>
@@ -18912,7 +18935,10 @@
                     <a:bodyPr/>
                     <a:lstStyle/>
                     <a:p>
-                      <a:endParaRPr lang="en-US" dirty="0"/>
+                      <a:r>
+                        <a:rPr lang="en-US" dirty="0"/>
+                        <a:t>53.1</a:t>
+                      </a:r>
                     </a:p>
                   </a:txBody>
                   <a:tcPr/>
@@ -18922,7 +18948,10 @@
                     <a:bodyPr/>
                     <a:lstStyle/>
                     <a:p>
-                      <a:endParaRPr lang="en-US" dirty="0"/>
+                      <a:r>
+                        <a:rPr lang="en-US" dirty="0"/>
+                        <a:t>61.1</a:t>
+                      </a:r>
                     </a:p>
                   </a:txBody>
                   <a:tcPr/>
@@ -18932,7 +18961,10 @@
                     <a:bodyPr/>
                     <a:lstStyle/>
                     <a:p>
-                      <a:endParaRPr lang="en-US" dirty="0"/>
+                      <a:r>
+                        <a:rPr lang="en-US" dirty="0"/>
+                        <a:t>12.20min</a:t>
+                      </a:r>
                     </a:p>
                   </a:txBody>
                   <a:tcPr/>
@@ -18942,7 +18974,10 @@
                     <a:bodyPr/>
                     <a:lstStyle/>
                     <a:p>
-                      <a:endParaRPr lang="en-US" dirty="0"/>
+                      <a:r>
+                        <a:rPr lang="en-US" dirty="0"/>
+                        <a:t>1.07</a:t>
+                      </a:r>
                     </a:p>
                   </a:txBody>
                   <a:tcPr/>
@@ -19027,7 +19062,10 @@
                     <a:bodyPr/>
                     <a:lstStyle/>
                     <a:p>
-                      <a:endParaRPr lang="en-US"/>
+                      <a:r>
+                        <a:rPr lang="en-US" dirty="0"/>
+                        <a:t>71.0</a:t>
+                      </a:r>
                     </a:p>
                   </a:txBody>
                   <a:tcPr/>
@@ -19037,7 +19075,10 @@
                     <a:bodyPr/>
                     <a:lstStyle/>
                     <a:p>
-                      <a:endParaRPr lang="en-US" dirty="0"/>
+                      <a:r>
+                        <a:rPr lang="en-US" dirty="0"/>
+                        <a:t>85.6</a:t>
+                      </a:r>
                     </a:p>
                   </a:txBody>
                   <a:tcPr/>
@@ -19047,7 +19088,10 @@
                     <a:bodyPr/>
                     <a:lstStyle/>
                     <a:p>
-                      <a:endParaRPr lang="en-US" dirty="0"/>
+                      <a:r>
+                        <a:rPr lang="en-US" dirty="0"/>
+                        <a:t>62.3</a:t>
+                      </a:r>
                     </a:p>
                   </a:txBody>
                   <a:tcPr/>
@@ -19057,7 +19101,10 @@
                     <a:bodyPr/>
                     <a:lstStyle/>
                     <a:p>
-                      <a:endParaRPr lang="en-US" dirty="0"/>
+                      <a:r>
+                        <a:rPr lang="en-US" dirty="0"/>
+                        <a:t>32.03min</a:t>
+                      </a:r>
                     </a:p>
                   </a:txBody>
                   <a:tcPr/>
@@ -19067,7 +19114,10 @@
                     <a:bodyPr/>
                     <a:lstStyle/>
                     <a:p>
-                      <a:endParaRPr lang="en-US" dirty="0"/>
+                      <a:r>
+                        <a:rPr lang="en-US" dirty="0"/>
+                        <a:t>1.01</a:t>
+                      </a:r>
                     </a:p>
                   </a:txBody>
                   <a:tcPr/>
@@ -19152,7 +19202,10 @@
                     <a:bodyPr/>
                     <a:lstStyle/>
                     <a:p>
-                      <a:endParaRPr lang="en-US"/>
+                      <a:r>
+                        <a:rPr lang="en-US" dirty="0"/>
+                        <a:t>92.5</a:t>
+                      </a:r>
                     </a:p>
                   </a:txBody>
                   <a:tcPr/>
@@ -19162,7 +19215,10 @@
                     <a:bodyPr/>
                     <a:lstStyle/>
                     <a:p>
-                      <a:endParaRPr lang="en-US" dirty="0"/>
+                      <a:r>
+                        <a:rPr lang="en-US" dirty="0"/>
+                        <a:t>43.3</a:t>
+                      </a:r>
                     </a:p>
                   </a:txBody>
                   <a:tcPr/>
@@ -19172,7 +19228,10 @@
                     <a:bodyPr/>
                     <a:lstStyle/>
                     <a:p>
-                      <a:endParaRPr lang="en-US" dirty="0"/>
+                      <a:r>
+                        <a:rPr lang="en-US" dirty="0"/>
+                        <a:t>53.3</a:t>
+                      </a:r>
                     </a:p>
                   </a:txBody>
                   <a:tcPr/>
@@ -19182,7 +19241,10 @@
                     <a:bodyPr/>
                     <a:lstStyle/>
                     <a:p>
-                      <a:endParaRPr lang="en-US" dirty="0"/>
+                      <a:r>
+                        <a:rPr lang="en-US" dirty="0"/>
+                        <a:t>26.27min</a:t>
+                      </a:r>
                     </a:p>
                   </a:txBody>
                   <a:tcPr/>
@@ -19192,7 +19254,10 @@
                     <a:bodyPr/>
                     <a:lstStyle/>
                     <a:p>
-                      <a:endParaRPr lang="en-US" dirty="0"/>
+                      <a:r>
+                        <a:rPr lang="en-US" dirty="0"/>
+                        <a:t>1.26</a:t>
+                      </a:r>
                     </a:p>
                   </a:txBody>
                   <a:tcPr/>
@@ -19278,7 +19343,7 @@
             <p:ph idx="1"/>
             <p:extLst>
               <p:ext uri="{D42A27DB-BD31-4B8C-83A1-F6EECF244321}">
-                <p14:modId xmlns:p14="http://schemas.microsoft.com/office/powerpoint/2010/main" val="3078447152"/>
+                <p14:modId xmlns:p14="http://schemas.microsoft.com/office/powerpoint/2010/main" val="761978584"/>
               </p:ext>
             </p:extLst>
           </p:nvPr>
@@ -19491,7 +19556,10 @@
                     <a:bodyPr/>
                     <a:lstStyle/>
                     <a:p>
-                      <a:endParaRPr lang="en-US" dirty="0"/>
+                      <a:r>
+                        <a:rPr lang="en-US" dirty="0"/>
+                        <a:t>87.1</a:t>
+                      </a:r>
                     </a:p>
                   </a:txBody>
                   <a:tcPr/>
@@ -19501,7 +19569,10 @@
                     <a:bodyPr/>
                     <a:lstStyle/>
                     <a:p>
-                      <a:endParaRPr lang="en-US" dirty="0"/>
+                      <a:r>
+                        <a:rPr lang="en-US" dirty="0"/>
+                        <a:t>61.3</a:t>
+                      </a:r>
                     </a:p>
                   </a:txBody>
                   <a:tcPr/>
@@ -19511,7 +19582,10 @@
                     <a:bodyPr/>
                     <a:lstStyle/>
                     <a:p>
-                      <a:endParaRPr lang="en-US" dirty="0"/>
+                      <a:r>
+                        <a:rPr lang="en-US" dirty="0"/>
+                        <a:t>66.5</a:t>
+                      </a:r>
                     </a:p>
                   </a:txBody>
                   <a:tcPr/>
@@ -19521,7 +19595,10 @@
                     <a:bodyPr/>
                     <a:lstStyle/>
                     <a:p>
-                      <a:endParaRPr lang="en-US" dirty="0"/>
+                      <a:r>
+                        <a:rPr lang="en-US" dirty="0"/>
+                        <a:t>58.87min</a:t>
+                      </a:r>
                     </a:p>
                   </a:txBody>
                   <a:tcPr/>
@@ -19531,7 +19608,10 @@
                     <a:bodyPr/>
                     <a:lstStyle/>
                     <a:p>
-                      <a:endParaRPr lang="en-US" dirty="0"/>
+                      <a:r>
+                        <a:rPr lang="en-US" dirty="0"/>
+                        <a:t>0.57</a:t>
+                      </a:r>
                     </a:p>
                   </a:txBody>
                   <a:tcPr/>
@@ -19591,7 +19671,10 @@
                     <a:bodyPr/>
                     <a:lstStyle/>
                     <a:p>
-                      <a:endParaRPr lang="en-US" dirty="0"/>
+                      <a:r>
+                        <a:rPr lang="en-US" dirty="0"/>
+                        <a:t>92.5</a:t>
+                      </a:r>
                     </a:p>
                   </a:txBody>
                   <a:tcPr/>
@@ -19601,7 +19684,10 @@
                     <a:bodyPr/>
                     <a:lstStyle/>
                     <a:p>
-                      <a:endParaRPr lang="en-US" dirty="0"/>
+                      <a:r>
+                        <a:rPr lang="en-US" dirty="0"/>
+                        <a:t>45.8</a:t>
+                      </a:r>
                     </a:p>
                   </a:txBody>
                   <a:tcPr/>
@@ -19611,7 +19697,10 @@
                     <a:bodyPr/>
                     <a:lstStyle/>
                     <a:p>
-                      <a:endParaRPr lang="en-US" dirty="0"/>
+                      <a:r>
+                        <a:rPr lang="en-US" dirty="0"/>
+                        <a:t>55.2</a:t>
+                      </a:r>
                     </a:p>
                   </a:txBody>
                   <a:tcPr/>
@@ -19621,7 +19710,10 @@
                     <a:bodyPr/>
                     <a:lstStyle/>
                     <a:p>
-                      <a:endParaRPr lang="en-US" dirty="0"/>
+                      <a:r>
+                        <a:rPr lang="en-US" dirty="0"/>
+                        <a:t>59.39min</a:t>
+                      </a:r>
                     </a:p>
                   </a:txBody>
                   <a:tcPr/>
@@ -19631,7 +19723,10 @@
                     <a:bodyPr/>
                     <a:lstStyle/>
                     <a:p>
-                      <a:endParaRPr lang="en-US" dirty="0"/>
+                      <a:r>
+                        <a:rPr lang="en-US" dirty="0"/>
+                        <a:t>0.52</a:t>
+                      </a:r>
                     </a:p>
                   </a:txBody>
                   <a:tcPr/>
@@ -19699,7 +19794,10 @@
                     <a:bodyPr/>
                     <a:lstStyle/>
                     <a:p>
-                      <a:endParaRPr lang="en-US"/>
+                      <a:r>
+                        <a:rPr lang="en-US" dirty="0"/>
+                        <a:t>84.9</a:t>
+                      </a:r>
                     </a:p>
                   </a:txBody>
                   <a:tcPr/>
@@ -19709,7 +19807,10 @@
                     <a:bodyPr/>
                     <a:lstStyle/>
                     <a:p>
-                      <a:endParaRPr lang="en-US" dirty="0"/>
+                      <a:r>
+                        <a:rPr lang="en-US" dirty="0"/>
+                        <a:t>62.7</a:t>
+                      </a:r>
                     </a:p>
                   </a:txBody>
                   <a:tcPr/>
@@ -19719,7 +19820,10 @@
                     <a:bodyPr/>
                     <a:lstStyle/>
                     <a:p>
-                      <a:endParaRPr lang="en-US" dirty="0"/>
+                      <a:r>
+                        <a:rPr lang="en-US" dirty="0"/>
+                        <a:t>67.2</a:t>
+                      </a:r>
                     </a:p>
                   </a:txBody>
                   <a:tcPr/>
@@ -19729,7 +19833,10 @@
                     <a:bodyPr/>
                     <a:lstStyle/>
                     <a:p>
-                      <a:endParaRPr lang="en-US" dirty="0"/>
+                      <a:r>
+                        <a:rPr lang="en-US" dirty="0"/>
+                        <a:t>80.35min</a:t>
+                      </a:r>
                     </a:p>
                   </a:txBody>
                   <a:tcPr/>
@@ -19739,7 +19846,10 @@
                     <a:bodyPr/>
                     <a:lstStyle/>
                     <a:p>
-                      <a:endParaRPr lang="en-US" dirty="0"/>
+                      <a:r>
+                        <a:rPr lang="en-US" dirty="0"/>
+                        <a:t>0.58</a:t>
+                      </a:r>
                     </a:p>
                   </a:txBody>
                   <a:tcPr/>
@@ -19807,7 +19917,10 @@
                     <a:bodyPr/>
                     <a:lstStyle/>
                     <a:p>
-                      <a:endParaRPr lang="en-US"/>
+                      <a:r>
+                        <a:rPr lang="en-US" dirty="0"/>
+                        <a:t>94.6</a:t>
+                      </a:r>
                     </a:p>
                   </a:txBody>
                   <a:tcPr/>
@@ -19817,7 +19930,10 @@
                     <a:bodyPr/>
                     <a:lstStyle/>
                     <a:p>
-                      <a:endParaRPr lang="en-US" dirty="0"/>
+                      <a:r>
+                        <a:rPr lang="en-US" dirty="0"/>
+                        <a:t>34.3</a:t>
+                      </a:r>
                     </a:p>
                   </a:txBody>
                   <a:tcPr/>
@@ -19827,7 +19943,10 @@
                     <a:bodyPr/>
                     <a:lstStyle/>
                     <a:p>
-                      <a:endParaRPr lang="en-US" dirty="0"/>
+                      <a:r>
+                        <a:rPr lang="en-US" dirty="0"/>
+                        <a:t>46.5</a:t>
+                      </a:r>
                     </a:p>
                   </a:txBody>
                   <a:tcPr/>
@@ -19837,7 +19956,10 @@
                     <a:bodyPr/>
                     <a:lstStyle/>
                     <a:p>
-                      <a:endParaRPr lang="en-US" dirty="0"/>
+                      <a:r>
+                        <a:rPr lang="en-US" dirty="0"/>
+                        <a:t>68.43min</a:t>
+                      </a:r>
                     </a:p>
                   </a:txBody>
                   <a:tcPr/>
@@ -19847,7 +19969,10 @@
                     <a:bodyPr/>
                     <a:lstStyle/>
                     <a:p>
-                      <a:endParaRPr lang="en-US" dirty="0"/>
+                      <a:r>
+                        <a:rPr lang="en-US" dirty="0"/>
+                        <a:t>0.59</a:t>
+                      </a:r>
                     </a:p>
                   </a:txBody>
                   <a:tcPr/>
@@ -19939,7 +20064,7 @@
             <p:ph idx="1"/>
             <p:extLst>
               <p:ext uri="{D42A27DB-BD31-4B8C-83A1-F6EECF244321}">
-                <p14:modId xmlns:p14="http://schemas.microsoft.com/office/powerpoint/2010/main" val="182978536"/>
+                <p14:modId xmlns:p14="http://schemas.microsoft.com/office/powerpoint/2010/main" val="2103404730"/>
               </p:ext>
             </p:extLst>
           </p:nvPr>
@@ -20152,7 +20277,10 @@
                     <a:bodyPr/>
                     <a:lstStyle/>
                     <a:p>
-                      <a:endParaRPr lang="en-US" dirty="0"/>
+                      <a:r>
+                        <a:rPr lang="en-US" dirty="0"/>
+                        <a:t>89.2</a:t>
+                      </a:r>
                     </a:p>
                   </a:txBody>
                   <a:tcPr/>
@@ -20162,7 +20290,10 @@
                     <a:bodyPr/>
                     <a:lstStyle/>
                     <a:p>
-                      <a:endParaRPr lang="en-US" dirty="0"/>
+                      <a:r>
+                        <a:rPr lang="en-US" dirty="0"/>
+                        <a:t>39.8</a:t>
+                      </a:r>
                     </a:p>
                   </a:txBody>
                   <a:tcPr/>
@@ -20172,7 +20303,10 @@
                     <a:bodyPr/>
                     <a:lstStyle/>
                     <a:p>
-                      <a:endParaRPr lang="en-US" dirty="0"/>
+                      <a:r>
+                        <a:rPr lang="en-US" dirty="0"/>
+                        <a:t>49.8</a:t>
+                      </a:r>
                     </a:p>
                   </a:txBody>
                   <a:tcPr/>
@@ -20182,7 +20316,10 @@
                     <a:bodyPr/>
                     <a:lstStyle/>
                     <a:p>
-                      <a:endParaRPr lang="en-US" dirty="0"/>
+                      <a:r>
+                        <a:rPr lang="en-US" dirty="0"/>
+                        <a:t>97.22min</a:t>
+                      </a:r>
                     </a:p>
                   </a:txBody>
                   <a:tcPr/>
@@ -20192,7 +20329,10 @@
                     <a:bodyPr/>
                     <a:lstStyle/>
                     <a:p>
-                      <a:endParaRPr lang="en-US" dirty="0"/>
+                      <a:r>
+                        <a:rPr lang="en-US" dirty="0"/>
+                        <a:t>0.31</a:t>
+                      </a:r>
                     </a:p>
                   </a:txBody>
                   <a:tcPr/>
@@ -20252,7 +20392,10 @@
                     <a:bodyPr/>
                     <a:lstStyle/>
                     <a:p>
-                      <a:endParaRPr lang="en-US" dirty="0"/>
+                      <a:r>
+                        <a:rPr lang="en-US" dirty="0"/>
+                        <a:t>89.2</a:t>
+                      </a:r>
                     </a:p>
                   </a:txBody>
                   <a:tcPr/>
@@ -20262,7 +20405,10 @@
                     <a:bodyPr/>
                     <a:lstStyle/>
                     <a:p>
-                      <a:endParaRPr lang="en-US" dirty="0"/>
+                      <a:r>
+                        <a:rPr lang="en-US" dirty="0"/>
+                        <a:t>33.0</a:t>
+                      </a:r>
                     </a:p>
                   </a:txBody>
                   <a:tcPr/>
@@ -20272,7 +20418,10 @@
                     <a:bodyPr/>
                     <a:lstStyle/>
                     <a:p>
-                      <a:endParaRPr lang="en-US" dirty="0"/>
+                      <a:r>
+                        <a:rPr lang="en-US" dirty="0"/>
+                        <a:t>44.3</a:t>
+                      </a:r>
                     </a:p>
                   </a:txBody>
                   <a:tcPr/>
@@ -20282,7 +20431,10 @@
                     <a:bodyPr/>
                     <a:lstStyle/>
                     <a:p>
-                      <a:endParaRPr lang="en-US" dirty="0"/>
+                      <a:r>
+                        <a:rPr lang="en-US" dirty="0"/>
+                        <a:t>101.53min</a:t>
+                      </a:r>
                     </a:p>
                   </a:txBody>
                   <a:tcPr/>
@@ -20292,7 +20444,10 @@
                     <a:bodyPr/>
                     <a:lstStyle/>
                     <a:p>
-                      <a:endParaRPr lang="en-US" dirty="0"/>
+                      <a:r>
+                        <a:rPr lang="en-US" dirty="0"/>
+                        <a:t>0.28</a:t>
+                      </a:r>
                     </a:p>
                   </a:txBody>
                   <a:tcPr/>
@@ -20360,7 +20515,10 @@
                     <a:bodyPr/>
                     <a:lstStyle/>
                     <a:p>
-                      <a:endParaRPr lang="en-US"/>
+                      <a:r>
+                        <a:rPr lang="en-US" dirty="0"/>
+                        <a:t>76.3</a:t>
+                      </a:r>
                     </a:p>
                   </a:txBody>
                   <a:tcPr/>
@@ -20370,7 +20528,10 @@
                     <a:bodyPr/>
                     <a:lstStyle/>
                     <a:p>
-                      <a:endParaRPr lang="en-US" dirty="0"/>
+                      <a:r>
+                        <a:rPr lang="en-US" dirty="0"/>
+                        <a:t>69.5</a:t>
+                      </a:r>
                     </a:p>
                   </a:txBody>
                   <a:tcPr/>
@@ -20380,7 +20541,10 @@
                     <a:bodyPr/>
                     <a:lstStyle/>
                     <a:p>
-                      <a:endParaRPr lang="en-US" dirty="0"/>
+                      <a:r>
+                        <a:rPr lang="en-US" dirty="0"/>
+                        <a:t>70.9</a:t>
+                      </a:r>
                     </a:p>
                   </a:txBody>
                   <a:tcPr/>
@@ -20390,7 +20554,10 @@
                     <a:bodyPr/>
                     <a:lstStyle/>
                     <a:p>
-                      <a:endParaRPr lang="en-US" dirty="0"/>
+                      <a:r>
+                        <a:rPr lang="en-US" dirty="0"/>
+                        <a:t>104.84min</a:t>
+                      </a:r>
                     </a:p>
                   </a:txBody>
                   <a:tcPr/>
@@ -20400,7 +20567,10 @@
                     <a:bodyPr/>
                     <a:lstStyle/>
                     <a:p>
-                      <a:endParaRPr lang="en-US" dirty="0"/>
+                      <a:r>
+                        <a:rPr lang="en-US" dirty="0"/>
+                        <a:t>0.32</a:t>
+                      </a:r>
                     </a:p>
                   </a:txBody>
                   <a:tcPr/>
@@ -20468,7 +20638,10 @@
                     <a:bodyPr/>
                     <a:lstStyle/>
                     <a:p>
-                      <a:endParaRPr lang="en-US"/>
+                      <a:r>
+                        <a:rPr lang="en-US" dirty="0"/>
+                        <a:t>94.6</a:t>
+                      </a:r>
                     </a:p>
                   </a:txBody>
                   <a:tcPr/>
@@ -20478,7 +20651,10 @@
                     <a:bodyPr/>
                     <a:lstStyle/>
                     <a:p>
-                      <a:endParaRPr lang="en-US" dirty="0"/>
+                      <a:r>
+                        <a:rPr lang="en-US" dirty="0"/>
+                        <a:t>21.5</a:t>
+                      </a:r>
                     </a:p>
                   </a:txBody>
                   <a:tcPr/>
@@ -20488,7 +20664,10 @@
                     <a:bodyPr/>
                     <a:lstStyle/>
                     <a:p>
-                      <a:endParaRPr lang="en-US" dirty="0"/>
+                      <a:r>
+                        <a:rPr lang="en-US" dirty="0"/>
+                        <a:t>36.3</a:t>
+                      </a:r>
                     </a:p>
                   </a:txBody>
                   <a:tcPr/>
@@ -20498,7 +20677,10 @@
                     <a:bodyPr/>
                     <a:lstStyle/>
                     <a:p>
-                      <a:endParaRPr lang="en-US" dirty="0"/>
+                      <a:r>
+                        <a:rPr lang="en-US" dirty="0"/>
+                        <a:t>112.19min</a:t>
+                      </a:r>
                     </a:p>
                   </a:txBody>
                   <a:tcPr/>
@@ -20508,7 +20690,10 @@
                     <a:bodyPr/>
                     <a:lstStyle/>
                     <a:p>
-                      <a:endParaRPr lang="en-US" dirty="0"/>
+                      <a:r>
+                        <a:rPr lang="en-US" dirty="0"/>
+                        <a:t>0.32</a:t>
+                      </a:r>
                     </a:p>
                   </a:txBody>
                   <a:tcPr/>
@@ -20818,29 +21003,29 @@
           <a:lstStyle/>
           <a:p>
             <a:r>
-              <a:rPr lang="en-US" sz="2000"/>
+              <a:rPr lang="en-US" sz="2000" dirty="0"/>
               <a:t>Go to </a:t>
             </a:r>
             <a:r>
-              <a:rPr lang="en-US" sz="2000">
+              <a:rPr lang="en-US" sz="2000" dirty="0">
                 <a:hlinkClick r:id="rId2"/>
               </a:rPr>
               <a:t>https://platform.openai.com/docs/models</a:t>
             </a:r>
             <a:r>
-              <a:rPr lang="en-US" sz="2000"/>
+              <a:rPr lang="en-US" sz="2000" dirty="0"/>
               <a:t> </a:t>
             </a:r>
           </a:p>
           <a:p>
             <a:r>
-              <a:rPr lang="en-US" sz="2000"/>
+              <a:rPr lang="en-US" sz="2000" dirty="0"/>
               <a:t>Select a specific model. </a:t>
             </a:r>
           </a:p>
           <a:p>
             <a:r>
-              <a:rPr lang="en-US" sz="2000"/>
+              <a:rPr lang="en-US" sz="2000" dirty="0"/>
               <a:t>Click at the copy symbol to get the model code and replace that in the full code. </a:t>
             </a:r>
           </a:p>

</xml_diff>

<commit_message>
test phase 2 validation for gpt 5 models
</commit_message>
<xml_diff>
--- a/Final_workflow.pptx
+++ b/Final_workflow.pptx
@@ -7037,7 +7037,7 @@
           <a:p>
             <a:fld id="{B91EF44D-EE28-F64D-96D8-55EF481E7992}" type="datetimeFigureOut">
               <a:rPr lang="en-US" smtClean="0"/>
-              <a:t>3/16/26</a:t>
+              <a:t>4/6/26</a:t>
             </a:fld>
             <a:endParaRPr lang="en-US"/>
           </a:p>
@@ -7235,7 +7235,7 @@
           <a:p>
             <a:fld id="{B91EF44D-EE28-F64D-96D8-55EF481E7992}" type="datetimeFigureOut">
               <a:rPr lang="en-US" smtClean="0"/>
-              <a:t>3/16/26</a:t>
+              <a:t>4/6/26</a:t>
             </a:fld>
             <a:endParaRPr lang="en-US"/>
           </a:p>
@@ -7443,7 +7443,7 @@
           <a:p>
             <a:fld id="{B91EF44D-EE28-F64D-96D8-55EF481E7992}" type="datetimeFigureOut">
               <a:rPr lang="en-US" smtClean="0"/>
-              <a:t>3/16/26</a:t>
+              <a:t>4/6/26</a:t>
             </a:fld>
             <a:endParaRPr lang="en-US"/>
           </a:p>
@@ -7641,7 +7641,7 @@
           <a:p>
             <a:fld id="{B91EF44D-EE28-F64D-96D8-55EF481E7992}" type="datetimeFigureOut">
               <a:rPr lang="en-US" smtClean="0"/>
-              <a:t>3/16/26</a:t>
+              <a:t>4/6/26</a:t>
             </a:fld>
             <a:endParaRPr lang="en-US"/>
           </a:p>
@@ -7916,7 +7916,7 @@
           <a:p>
             <a:fld id="{B91EF44D-EE28-F64D-96D8-55EF481E7992}" type="datetimeFigureOut">
               <a:rPr lang="en-US" smtClean="0"/>
-              <a:t>3/16/26</a:t>
+              <a:t>4/6/26</a:t>
             </a:fld>
             <a:endParaRPr lang="en-US"/>
           </a:p>
@@ -8181,7 +8181,7 @@
           <a:p>
             <a:fld id="{B91EF44D-EE28-F64D-96D8-55EF481E7992}" type="datetimeFigureOut">
               <a:rPr lang="en-US" smtClean="0"/>
-              <a:t>3/16/26</a:t>
+              <a:t>4/6/26</a:t>
             </a:fld>
             <a:endParaRPr lang="en-US"/>
           </a:p>
@@ -8593,7 +8593,7 @@
           <a:p>
             <a:fld id="{B91EF44D-EE28-F64D-96D8-55EF481E7992}" type="datetimeFigureOut">
               <a:rPr lang="en-US" smtClean="0"/>
-              <a:t>3/16/26</a:t>
+              <a:t>4/6/26</a:t>
             </a:fld>
             <a:endParaRPr lang="en-US"/>
           </a:p>
@@ -8734,7 +8734,7 @@
           <a:p>
             <a:fld id="{B91EF44D-EE28-F64D-96D8-55EF481E7992}" type="datetimeFigureOut">
               <a:rPr lang="en-US" smtClean="0"/>
-              <a:t>3/16/26</a:t>
+              <a:t>4/6/26</a:t>
             </a:fld>
             <a:endParaRPr lang="en-US"/>
           </a:p>
@@ -8847,7 +8847,7 @@
           <a:p>
             <a:fld id="{B91EF44D-EE28-F64D-96D8-55EF481E7992}" type="datetimeFigureOut">
               <a:rPr lang="en-US" smtClean="0"/>
-              <a:t>3/16/26</a:t>
+              <a:t>4/6/26</a:t>
             </a:fld>
             <a:endParaRPr lang="en-US"/>
           </a:p>
@@ -9158,7 +9158,7 @@
           <a:p>
             <a:fld id="{B91EF44D-EE28-F64D-96D8-55EF481E7992}" type="datetimeFigureOut">
               <a:rPr lang="en-US" smtClean="0"/>
-              <a:t>3/16/26</a:t>
+              <a:t>4/6/26</a:t>
             </a:fld>
             <a:endParaRPr lang="en-US"/>
           </a:p>
@@ -9446,7 +9446,7 @@
           <a:p>
             <a:fld id="{B91EF44D-EE28-F64D-96D8-55EF481E7992}" type="datetimeFigureOut">
               <a:rPr lang="en-US" smtClean="0"/>
-              <a:t>3/16/26</a:t>
+              <a:t>4/6/26</a:t>
             </a:fld>
             <a:endParaRPr lang="en-US"/>
           </a:p>
@@ -9687,7 +9687,7 @@
           <a:p>
             <a:fld id="{B91EF44D-EE28-F64D-96D8-55EF481E7992}" type="datetimeFigureOut">
               <a:rPr lang="en-US" smtClean="0"/>
-              <a:t>3/16/26</a:t>
+              <a:t>4/6/26</a:t>
             </a:fld>
             <a:endParaRPr lang="en-US"/>
           </a:p>
@@ -21907,7 +21907,7 @@
             <p:ph idx="1"/>
             <p:extLst>
               <p:ext uri="{D42A27DB-BD31-4B8C-83A1-F6EECF244321}">
-                <p14:modId xmlns:p14="http://schemas.microsoft.com/office/powerpoint/2010/main" val="594810564"/>
+                <p14:modId xmlns:p14="http://schemas.microsoft.com/office/powerpoint/2010/main" val="2472181477"/>
               </p:ext>
             </p:extLst>
           </p:nvPr>
@@ -22120,7 +22120,10 @@
                     <a:bodyPr/>
                     <a:lstStyle/>
                     <a:p>
-                      <a:endParaRPr lang="en-US" dirty="0"/>
+                      <a:r>
+                        <a:rPr lang="en-US" dirty="0"/>
+                        <a:t>89.2</a:t>
+                      </a:r>
                     </a:p>
                   </a:txBody>
                   <a:tcPr/>
@@ -22130,7 +22133,10 @@
                     <a:bodyPr/>
                     <a:lstStyle/>
                     <a:p>
-                      <a:endParaRPr lang="en-US" dirty="0"/>
+                      <a:r>
+                        <a:rPr lang="en-US" dirty="0"/>
+                        <a:t>59.6</a:t>
+                      </a:r>
                     </a:p>
                   </a:txBody>
                   <a:tcPr/>
@@ -22140,7 +22146,10 @@
                     <a:bodyPr/>
                     <a:lstStyle/>
                     <a:p>
-                      <a:endParaRPr lang="en-US" dirty="0"/>
+                      <a:r>
+                        <a:rPr lang="en-US" dirty="0"/>
+                        <a:t>63.4</a:t>
+                      </a:r>
                     </a:p>
                   </a:txBody>
                   <a:tcPr/>
@@ -22150,7 +22159,10 @@
                     <a:bodyPr/>
                     <a:lstStyle/>
                     <a:p>
-                      <a:endParaRPr lang="en-US" dirty="0"/>
+                      <a:r>
+                        <a:rPr lang="en-US" dirty="0"/>
+                        <a:t>39.52min</a:t>
+                      </a:r>
                     </a:p>
                   </a:txBody>
                   <a:tcPr/>
@@ -22160,7 +22172,10 @@
                     <a:bodyPr/>
                     <a:lstStyle/>
                     <a:p>
-                      <a:endParaRPr lang="en-US" dirty="0"/>
+                      <a:r>
+                        <a:rPr lang="en-US" dirty="0"/>
+                        <a:t>5.73</a:t>
+                      </a:r>
                     </a:p>
                   </a:txBody>
                   <a:tcPr/>
@@ -22237,7 +22252,10 @@
                     <a:bodyPr/>
                     <a:lstStyle/>
                     <a:p>
-                      <a:endParaRPr lang="en-US" dirty="0"/>
+                      <a:r>
+                        <a:rPr lang="en-US" dirty="0"/>
+                        <a:t>96.6</a:t>
+                      </a:r>
                     </a:p>
                   </a:txBody>
                   <a:tcPr/>
@@ -22247,7 +22265,10 @@
                     <a:bodyPr/>
                     <a:lstStyle/>
                     <a:p>
-                      <a:endParaRPr lang="en-US" dirty="0"/>
+                      <a:r>
+                        <a:rPr lang="en-US" dirty="0"/>
+                        <a:t>41.2</a:t>
+                      </a:r>
                     </a:p>
                   </a:txBody>
                   <a:tcPr/>
@@ -22257,7 +22278,10 @@
                     <a:bodyPr/>
                     <a:lstStyle/>
                     <a:p>
-                      <a:endParaRPr lang="en-US" dirty="0"/>
+                      <a:r>
+                        <a:rPr lang="en-US" dirty="0"/>
+                        <a:t>48.2</a:t>
+                      </a:r>
                     </a:p>
                   </a:txBody>
                   <a:tcPr/>
@@ -22267,7 +22291,10 @@
                     <a:bodyPr/>
                     <a:lstStyle/>
                     <a:p>
-                      <a:endParaRPr lang="en-US" dirty="0"/>
+                      <a:r>
+                        <a:rPr lang="en-US" dirty="0"/>
+                        <a:t>38.79min</a:t>
+                      </a:r>
                     </a:p>
                   </a:txBody>
                   <a:tcPr/>
@@ -22277,7 +22304,10 @@
                     <a:bodyPr/>
                     <a:lstStyle/>
                     <a:p>
-                      <a:endParaRPr lang="en-US" dirty="0"/>
+                      <a:r>
+                        <a:rPr lang="en-US" dirty="0"/>
+                        <a:t>4.51</a:t>
+                      </a:r>
                     </a:p>
                   </a:txBody>
                   <a:tcPr/>
@@ -22362,7 +22392,10 @@
                     <a:bodyPr/>
                     <a:lstStyle/>
                     <a:p>
-                      <a:endParaRPr lang="en-US"/>
+                      <a:r>
+                        <a:rPr lang="en-US" dirty="0"/>
+                        <a:t>82.8</a:t>
+                      </a:r>
                     </a:p>
                   </a:txBody>
                   <a:tcPr/>
@@ -22372,7 +22405,10 @@
                     <a:bodyPr/>
                     <a:lstStyle/>
                     <a:p>
-                      <a:endParaRPr lang="en-US" dirty="0"/>
+                      <a:r>
+                        <a:rPr lang="en-US" dirty="0"/>
+                        <a:t>81.1</a:t>
+                      </a:r>
                     </a:p>
                   </a:txBody>
                   <a:tcPr/>
@@ -22382,7 +22418,10 @@
                     <a:bodyPr/>
                     <a:lstStyle/>
                     <a:p>
-                      <a:endParaRPr lang="en-US" dirty="0"/>
+                      <a:r>
+                        <a:rPr lang="en-US" dirty="0"/>
+                        <a:t>81.3</a:t>
+                      </a:r>
                     </a:p>
                   </a:txBody>
                   <a:tcPr/>
@@ -22392,7 +22431,10 @@
                     <a:bodyPr/>
                     <a:lstStyle/>
                     <a:p>
-                      <a:endParaRPr lang="en-US" dirty="0"/>
+                      <a:r>
+                        <a:rPr lang="en-US" dirty="0"/>
+                        <a:t>74.19min</a:t>
+                      </a:r>
                     </a:p>
                   </a:txBody>
                   <a:tcPr/>
@@ -22402,7 +22444,10 @@
                     <a:bodyPr/>
                     <a:lstStyle/>
                     <a:p>
-                      <a:endParaRPr lang="en-US" dirty="0"/>
+                      <a:r>
+                        <a:rPr lang="en-US" dirty="0"/>
+                        <a:t>4.76</a:t>
+                      </a:r>
                     </a:p>
                   </a:txBody>
                   <a:tcPr/>
@@ -22487,7 +22532,10 @@
                     <a:bodyPr/>
                     <a:lstStyle/>
                     <a:p>
-                      <a:endParaRPr lang="en-US"/>
+                      <a:r>
+                        <a:rPr lang="en-US" dirty="0"/>
+                        <a:t>94.6</a:t>
+                      </a:r>
                     </a:p>
                   </a:txBody>
                   <a:tcPr/>
@@ -22497,7 +22545,10 @@
                     <a:bodyPr/>
                     <a:lstStyle/>
                     <a:p>
-                      <a:endParaRPr lang="en-US" dirty="0"/>
+                      <a:r>
+                        <a:rPr lang="en-US" dirty="0"/>
+                        <a:t>21.5</a:t>
+                      </a:r>
                     </a:p>
                   </a:txBody>
                   <a:tcPr/>
@@ -22507,7 +22558,10 @@
                     <a:bodyPr/>
                     <a:lstStyle/>
                     <a:p>
-                      <a:endParaRPr lang="en-US" dirty="0"/>
+                      <a:r>
+                        <a:rPr lang="en-US" dirty="0"/>
+                        <a:t>36.3</a:t>
+                      </a:r>
                     </a:p>
                   </a:txBody>
                   <a:tcPr/>
@@ -22517,7 +22571,10 @@
                     <a:bodyPr/>
                     <a:lstStyle/>
                     <a:p>
-                      <a:endParaRPr lang="en-US" dirty="0"/>
+                      <a:r>
+                        <a:rPr lang="en-US" dirty="0"/>
+                        <a:t>72.27min</a:t>
+                      </a:r>
                     </a:p>
                   </a:txBody>
                   <a:tcPr/>
@@ -22527,7 +22584,10 @@
                     <a:bodyPr/>
                     <a:lstStyle/>
                     <a:p>
-                      <a:endParaRPr lang="en-US" dirty="0"/>
+                      <a:r>
+                        <a:rPr lang="en-US" dirty="0"/>
+                        <a:t>4.85</a:t>
+                      </a:r>
                     </a:p>
                   </a:txBody>
                   <a:tcPr/>
@@ -22588,7 +22648,7 @@
             <p:ph idx="1"/>
             <p:extLst>
               <p:ext uri="{D42A27DB-BD31-4B8C-83A1-F6EECF244321}">
-                <p14:modId xmlns:p14="http://schemas.microsoft.com/office/powerpoint/2010/main" val="3288453799"/>
+                <p14:modId xmlns:p14="http://schemas.microsoft.com/office/powerpoint/2010/main" val="2904411943"/>
               </p:ext>
             </p:extLst>
           </p:nvPr>
@@ -22801,7 +22861,10 @@
                     <a:bodyPr/>
                     <a:lstStyle/>
                     <a:p>
-                      <a:endParaRPr lang="en-US" dirty="0"/>
+                      <a:r>
+                        <a:rPr lang="en-US" dirty="0"/>
+                        <a:t>88.8</a:t>
+                      </a:r>
                     </a:p>
                   </a:txBody>
                   <a:tcPr/>
@@ -22811,7 +22874,10 @@
                     <a:bodyPr/>
                     <a:lstStyle/>
                     <a:p>
-                      <a:endParaRPr lang="en-US" dirty="0"/>
+                      <a:r>
+                        <a:rPr lang="en-US" dirty="0"/>
+                        <a:t>63.5</a:t>
+                      </a:r>
                     </a:p>
                   </a:txBody>
                   <a:tcPr/>
@@ -22821,7 +22887,10 @@
                     <a:bodyPr/>
                     <a:lstStyle/>
                     <a:p>
-                      <a:endParaRPr lang="en-US" dirty="0"/>
+                      <a:r>
+                        <a:rPr lang="en-US" dirty="0"/>
+                        <a:t>66.7</a:t>
+                      </a:r>
                     </a:p>
                   </a:txBody>
                   <a:tcPr/>
@@ -22831,7 +22900,10 @@
                     <a:bodyPr/>
                     <a:lstStyle/>
                     <a:p>
-                      <a:endParaRPr lang="en-US" dirty="0"/>
+                      <a:r>
+                        <a:rPr lang="en-US" dirty="0"/>
+                        <a:t>223.20min</a:t>
+                      </a:r>
                     </a:p>
                   </a:txBody>
                   <a:tcPr/>
@@ -22841,7 +22913,10 @@
                     <a:bodyPr/>
                     <a:lstStyle/>
                     <a:p>
-                      <a:endParaRPr lang="en-US" dirty="0"/>
+                      <a:r>
+                        <a:rPr lang="en-US" dirty="0"/>
+                        <a:t>3.22</a:t>
+                      </a:r>
                     </a:p>
                   </a:txBody>
                   <a:tcPr/>
@@ -22901,7 +22976,10 @@
                     <a:bodyPr/>
                     <a:lstStyle/>
                     <a:p>
-                      <a:endParaRPr lang="en-US" dirty="0"/>
+                      <a:r>
+                        <a:rPr lang="en-US" dirty="0"/>
+                        <a:t>91.4</a:t>
+                      </a:r>
                     </a:p>
                   </a:txBody>
                   <a:tcPr/>
@@ -22911,7 +22989,10 @@
                     <a:bodyPr/>
                     <a:lstStyle/>
                     <a:p>
-                      <a:endParaRPr lang="en-US" dirty="0"/>
+                      <a:r>
+                        <a:rPr lang="en-US" dirty="0"/>
+                        <a:t>34.2</a:t>
+                      </a:r>
                     </a:p>
                   </a:txBody>
                   <a:tcPr/>
@@ -22921,7 +23002,10 @@
                     <a:bodyPr/>
                     <a:lstStyle/>
                     <a:p>
-                      <a:endParaRPr lang="en-US" dirty="0"/>
+                      <a:r>
+                        <a:rPr lang="en-US" dirty="0"/>
+                        <a:t>41.4</a:t>
+                      </a:r>
                     </a:p>
                   </a:txBody>
                   <a:tcPr/>
@@ -22931,7 +23015,10 @@
                     <a:bodyPr/>
                     <a:lstStyle/>
                     <a:p>
-                      <a:endParaRPr lang="en-US" dirty="0"/>
+                      <a:r>
+                        <a:rPr lang="en-US" dirty="0"/>
+                        <a:t>239.50min</a:t>
+                      </a:r>
                     </a:p>
                   </a:txBody>
                   <a:tcPr/>
@@ -22941,7 +23028,10 @@
                     <a:bodyPr/>
                     <a:lstStyle/>
                     <a:p>
-                      <a:endParaRPr lang="en-US" dirty="0"/>
+                      <a:r>
+                        <a:rPr lang="en-US" dirty="0"/>
+                        <a:t>2.18</a:t>
+                      </a:r>
                     </a:p>
                   </a:txBody>
                   <a:tcPr/>
@@ -23009,7 +23099,10 @@
                     <a:bodyPr/>
                     <a:lstStyle/>
                     <a:p>
-                      <a:endParaRPr lang="en-US"/>
+                      <a:r>
+                        <a:rPr lang="en-US" dirty="0"/>
+                        <a:t>88.4</a:t>
+                      </a:r>
                     </a:p>
                   </a:txBody>
                   <a:tcPr/>
@@ -23019,7 +23112,10 @@
                     <a:bodyPr/>
                     <a:lstStyle/>
                     <a:p>
-                      <a:endParaRPr lang="en-US" dirty="0"/>
+                      <a:r>
+                        <a:rPr lang="en-US" dirty="0"/>
+                        <a:t>64.6</a:t>
+                      </a:r>
                     </a:p>
                   </a:txBody>
                   <a:tcPr/>
@@ -23029,7 +23125,10 @@
                     <a:bodyPr/>
                     <a:lstStyle/>
                     <a:p>
-                      <a:endParaRPr lang="en-US" dirty="0"/>
+                      <a:r>
+                        <a:rPr lang="en-US" dirty="0"/>
+                        <a:t>67.6</a:t>
+                      </a:r>
                     </a:p>
                   </a:txBody>
                   <a:tcPr/>
@@ -23039,7 +23138,10 @@
                     <a:bodyPr/>
                     <a:lstStyle/>
                     <a:p>
-                      <a:endParaRPr lang="en-US" dirty="0"/>
+                      <a:r>
+                        <a:rPr lang="en-US" dirty="0"/>
+                        <a:t>302.22min</a:t>
+                      </a:r>
                     </a:p>
                   </a:txBody>
                   <a:tcPr/>
@@ -23049,7 +23151,10 @@
                     <a:bodyPr/>
                     <a:lstStyle/>
                     <a:p>
-                      <a:endParaRPr lang="en-US" dirty="0"/>
+                      <a:r>
+                        <a:rPr lang="en-US" dirty="0"/>
+                        <a:t>2.41</a:t>
+                      </a:r>
                     </a:p>
                   </a:txBody>
                   <a:tcPr/>
@@ -23117,7 +23222,10 @@
                     <a:bodyPr/>
                     <a:lstStyle/>
                     <a:p>
-                      <a:endParaRPr lang="en-US"/>
+                      <a:r>
+                        <a:rPr lang="en-US" dirty="0"/>
+                        <a:t>94.4</a:t>
+                      </a:r>
                     </a:p>
                   </a:txBody>
                   <a:tcPr/>
@@ -23127,7 +23235,10 @@
                     <a:bodyPr/>
                     <a:lstStyle/>
                     <a:p>
-                      <a:endParaRPr lang="en-US" dirty="0"/>
+                      <a:r>
+                        <a:rPr lang="en-US" dirty="0"/>
+                        <a:t>25.7</a:t>
+                      </a:r>
                     </a:p>
                   </a:txBody>
                   <a:tcPr/>
@@ -23137,7 +23248,10 @@
                     <a:bodyPr/>
                     <a:lstStyle/>
                     <a:p>
-                      <a:endParaRPr lang="en-US" dirty="0"/>
+                      <a:r>
+                        <a:rPr lang="en-US" dirty="0"/>
+                        <a:t>34.4</a:t>
+                      </a:r>
                     </a:p>
                   </a:txBody>
                   <a:tcPr/>
@@ -23147,7 +23261,10 @@
                     <a:bodyPr/>
                     <a:lstStyle/>
                     <a:p>
-                      <a:endParaRPr lang="en-US" dirty="0"/>
+                      <a:r>
+                        <a:rPr lang="en-US" dirty="0"/>
+                        <a:t>273.22min</a:t>
+                      </a:r>
                     </a:p>
                   </a:txBody>
                   <a:tcPr/>
@@ -23157,7 +23274,10 @@
                     <a:bodyPr/>
                     <a:lstStyle/>
                     <a:p>
-                      <a:endParaRPr lang="en-US" dirty="0"/>
+                      <a:r>
+                        <a:rPr lang="en-US" dirty="0"/>
+                        <a:t>3.18</a:t>
+                      </a:r>
                     </a:p>
                   </a:txBody>
                   <a:tcPr/>
@@ -23242,7 +23362,7 @@
           <p:nvPr>
             <p:extLst>
               <p:ext uri="{D42A27DB-BD31-4B8C-83A1-F6EECF244321}">
-                <p14:modId xmlns:p14="http://schemas.microsoft.com/office/powerpoint/2010/main" val="3974618170"/>
+                <p14:modId xmlns:p14="http://schemas.microsoft.com/office/powerpoint/2010/main" val="1923509951"/>
               </p:ext>
             </p:extLst>
           </p:nvPr>
@@ -23455,7 +23575,10 @@
                     <a:bodyPr/>
                     <a:lstStyle/>
                     <a:p>
-                      <a:endParaRPr lang="en-US" dirty="0"/>
+                      <a:r>
+                        <a:rPr lang="en-US" dirty="0"/>
+                        <a:t>93.5</a:t>
+                      </a:r>
                     </a:p>
                   </a:txBody>
                   <a:tcPr/>
@@ -23465,7 +23588,10 @@
                     <a:bodyPr/>
                     <a:lstStyle/>
                     <a:p>
-                      <a:endParaRPr lang="en-US" dirty="0"/>
+                      <a:r>
+                        <a:rPr lang="en-US" dirty="0"/>
+                        <a:t>38.9</a:t>
+                      </a:r>
                     </a:p>
                   </a:txBody>
                   <a:tcPr/>
@@ -23475,7 +23601,10 @@
                     <a:bodyPr/>
                     <a:lstStyle/>
                     <a:p>
-                      <a:endParaRPr lang="en-US" dirty="0"/>
+                      <a:r>
+                        <a:rPr lang="en-US" dirty="0"/>
+                        <a:t>45.8</a:t>
+                      </a:r>
                     </a:p>
                   </a:txBody>
                   <a:tcPr/>
@@ -23485,7 +23614,10 @@
                     <a:bodyPr/>
                     <a:lstStyle/>
                     <a:p>
-                      <a:endParaRPr lang="en-US" dirty="0"/>
+                      <a:r>
+                        <a:rPr lang="en-US" dirty="0"/>
+                        <a:t>273.15min</a:t>
+                      </a:r>
                     </a:p>
                   </a:txBody>
                   <a:tcPr/>
@@ -23495,7 +23627,10 @@
                     <a:bodyPr/>
                     <a:lstStyle/>
                     <a:p>
-                      <a:endParaRPr lang="en-US" dirty="0"/>
+                      <a:r>
+                        <a:rPr lang="en-US" dirty="0"/>
+                        <a:t>1.25</a:t>
+                      </a:r>
                     </a:p>
                   </a:txBody>
                   <a:tcPr/>
@@ -23555,7 +23690,10 @@
                     <a:bodyPr/>
                     <a:lstStyle/>
                     <a:p>
-                      <a:endParaRPr lang="en-US" dirty="0"/>
+                      <a:r>
+                        <a:rPr lang="en-US" dirty="0"/>
+                        <a:t>92.2</a:t>
+                      </a:r>
                     </a:p>
                   </a:txBody>
                   <a:tcPr/>
@@ -23565,7 +23703,10 @@
                     <a:bodyPr/>
                     <a:lstStyle/>
                     <a:p>
-                      <a:endParaRPr lang="en-US" dirty="0"/>
+                      <a:r>
+                        <a:rPr lang="en-US" dirty="0"/>
+                        <a:t>26.0</a:t>
+                      </a:r>
                     </a:p>
                   </a:txBody>
                   <a:tcPr/>
@@ -23575,7 +23716,10 @@
                     <a:bodyPr/>
                     <a:lstStyle/>
                     <a:p>
-                      <a:endParaRPr lang="en-US" dirty="0"/>
+                      <a:r>
+                        <a:rPr lang="en-US" dirty="0"/>
+                        <a:t>34.3</a:t>
+                      </a:r>
                     </a:p>
                   </a:txBody>
                   <a:tcPr/>
@@ -23585,7 +23729,10 @@
                     <a:bodyPr/>
                     <a:lstStyle/>
                     <a:p>
-                      <a:endParaRPr lang="en-US" dirty="0"/>
+                      <a:r>
+                        <a:rPr lang="en-US" dirty="0"/>
+                        <a:t>245.33min</a:t>
+                      </a:r>
                     </a:p>
                   </a:txBody>
                   <a:tcPr/>
@@ -23595,7 +23742,10 @@
                     <a:bodyPr/>
                     <a:lstStyle/>
                     <a:p>
-                      <a:endParaRPr lang="en-US" dirty="0"/>
+                      <a:r>
+                        <a:rPr lang="en-US" dirty="0"/>
+                        <a:t>1.08</a:t>
+                      </a:r>
                     </a:p>
                   </a:txBody>
                   <a:tcPr/>
@@ -23663,7 +23813,10 @@
                     <a:bodyPr/>
                     <a:lstStyle/>
                     <a:p>
-                      <a:endParaRPr lang="en-US"/>
+                      <a:r>
+                        <a:rPr lang="en-US" dirty="0"/>
+                        <a:t>83.6</a:t>
+                      </a:r>
                     </a:p>
                   </a:txBody>
                   <a:tcPr/>
@@ -23673,7 +23826,10 @@
                     <a:bodyPr/>
                     <a:lstStyle/>
                     <a:p>
-                      <a:endParaRPr lang="en-US" dirty="0"/>
+                      <a:r>
+                        <a:rPr lang="en-US" dirty="0"/>
+                        <a:t>74.9</a:t>
+                      </a:r>
                     </a:p>
                   </a:txBody>
                   <a:tcPr/>
@@ -23683,7 +23839,10 @@
                     <a:bodyPr/>
                     <a:lstStyle/>
                     <a:p>
-                      <a:endParaRPr lang="en-US" dirty="0"/>
+                      <a:r>
+                        <a:rPr lang="en-US" dirty="0"/>
+                        <a:t>76.0</a:t>
+                      </a:r>
                     </a:p>
                   </a:txBody>
                   <a:tcPr/>
@@ -23693,7 +23852,10 @@
                     <a:bodyPr/>
                     <a:lstStyle/>
                     <a:p>
-                      <a:endParaRPr lang="en-US" dirty="0"/>
+                      <a:r>
+                        <a:rPr lang="en-US" dirty="0"/>
+                        <a:t>293.26min</a:t>
+                      </a:r>
                     </a:p>
                   </a:txBody>
                   <a:tcPr/>
@@ -23703,7 +23865,10 @@
                     <a:bodyPr/>
                     <a:lstStyle/>
                     <a:p>
-                      <a:endParaRPr lang="en-US" dirty="0"/>
+                      <a:r>
+                        <a:rPr lang="en-US" dirty="0"/>
+                        <a:t>1.24</a:t>
+                      </a:r>
                     </a:p>
                   </a:txBody>
                   <a:tcPr/>
@@ -23771,7 +23936,10 @@
                     <a:bodyPr/>
                     <a:lstStyle/>
                     <a:p>
-                      <a:endParaRPr lang="en-US"/>
+                      <a:r>
+                        <a:rPr lang="en-US" dirty="0"/>
+                        <a:t>96.1</a:t>
+                      </a:r>
                     </a:p>
                   </a:txBody>
                   <a:tcPr/>
@@ -23781,7 +23949,10 @@
                     <a:bodyPr/>
                     <a:lstStyle/>
                     <a:p>
-                      <a:endParaRPr lang="en-US" dirty="0"/>
+                      <a:r>
+                        <a:rPr lang="en-US" dirty="0"/>
+                        <a:t>17.1</a:t>
+                      </a:r>
                     </a:p>
                   </a:txBody>
                   <a:tcPr/>
@@ -23791,7 +23962,10 @@
                     <a:bodyPr/>
                     <a:lstStyle/>
                     <a:p>
-                      <a:endParaRPr lang="en-US" dirty="0"/>
+                      <a:r>
+                        <a:rPr lang="en-US" dirty="0"/>
+                        <a:t>27.0</a:t>
+                      </a:r>
                     </a:p>
                   </a:txBody>
                   <a:tcPr/>
@@ -23801,7 +23975,10 @@
                     <a:bodyPr/>
                     <a:lstStyle/>
                     <a:p>
-                      <a:endParaRPr lang="en-US" dirty="0"/>
+                      <a:r>
+                        <a:rPr lang="en-US" dirty="0"/>
+                        <a:t>325.76min</a:t>
+                      </a:r>
                     </a:p>
                   </a:txBody>
                   <a:tcPr/>
@@ -23811,7 +23988,10 @@
                     <a:bodyPr/>
                     <a:lstStyle/>
                     <a:p>
-                      <a:endParaRPr lang="en-US" dirty="0"/>
+                      <a:r>
+                        <a:rPr lang="en-US" dirty="0"/>
+                        <a:t>1.2</a:t>
+                      </a:r>
                     </a:p>
                   </a:txBody>
                   <a:tcPr/>

</xml_diff>

<commit_message>
complete gpt 5 test, zero shot and few shot for phase 1 and 2
</commit_message>
<xml_diff>
--- a/Final_workflow.pptx
+++ b/Final_workflow.pptx
@@ -7037,7 +7037,7 @@
           <a:p>
             <a:fld id="{B91EF44D-EE28-F64D-96D8-55EF481E7992}" type="datetimeFigureOut">
               <a:rPr lang="en-US" smtClean="0"/>
-              <a:t>4/6/26</a:t>
+              <a:t>4/13/26</a:t>
             </a:fld>
             <a:endParaRPr lang="en-US"/>
           </a:p>
@@ -7235,7 +7235,7 @@
           <a:p>
             <a:fld id="{B91EF44D-EE28-F64D-96D8-55EF481E7992}" type="datetimeFigureOut">
               <a:rPr lang="en-US" smtClean="0"/>
-              <a:t>4/6/26</a:t>
+              <a:t>4/13/26</a:t>
             </a:fld>
             <a:endParaRPr lang="en-US"/>
           </a:p>
@@ -7443,7 +7443,7 @@
           <a:p>
             <a:fld id="{B91EF44D-EE28-F64D-96D8-55EF481E7992}" type="datetimeFigureOut">
               <a:rPr lang="en-US" smtClean="0"/>
-              <a:t>4/6/26</a:t>
+              <a:t>4/13/26</a:t>
             </a:fld>
             <a:endParaRPr lang="en-US"/>
           </a:p>
@@ -7641,7 +7641,7 @@
           <a:p>
             <a:fld id="{B91EF44D-EE28-F64D-96D8-55EF481E7992}" type="datetimeFigureOut">
               <a:rPr lang="en-US" smtClean="0"/>
-              <a:t>4/6/26</a:t>
+              <a:t>4/13/26</a:t>
             </a:fld>
             <a:endParaRPr lang="en-US"/>
           </a:p>
@@ -7916,7 +7916,7 @@
           <a:p>
             <a:fld id="{B91EF44D-EE28-F64D-96D8-55EF481E7992}" type="datetimeFigureOut">
               <a:rPr lang="en-US" smtClean="0"/>
-              <a:t>4/6/26</a:t>
+              <a:t>4/13/26</a:t>
             </a:fld>
             <a:endParaRPr lang="en-US"/>
           </a:p>
@@ -8181,7 +8181,7 @@
           <a:p>
             <a:fld id="{B91EF44D-EE28-F64D-96D8-55EF481E7992}" type="datetimeFigureOut">
               <a:rPr lang="en-US" smtClean="0"/>
-              <a:t>4/6/26</a:t>
+              <a:t>4/13/26</a:t>
             </a:fld>
             <a:endParaRPr lang="en-US"/>
           </a:p>
@@ -8593,7 +8593,7 @@
           <a:p>
             <a:fld id="{B91EF44D-EE28-F64D-96D8-55EF481E7992}" type="datetimeFigureOut">
               <a:rPr lang="en-US" smtClean="0"/>
-              <a:t>4/6/26</a:t>
+              <a:t>4/13/26</a:t>
             </a:fld>
             <a:endParaRPr lang="en-US"/>
           </a:p>
@@ -8734,7 +8734,7 @@
           <a:p>
             <a:fld id="{B91EF44D-EE28-F64D-96D8-55EF481E7992}" type="datetimeFigureOut">
               <a:rPr lang="en-US" smtClean="0"/>
-              <a:t>4/6/26</a:t>
+              <a:t>4/13/26</a:t>
             </a:fld>
             <a:endParaRPr lang="en-US"/>
           </a:p>
@@ -8847,7 +8847,7 @@
           <a:p>
             <a:fld id="{B91EF44D-EE28-F64D-96D8-55EF481E7992}" type="datetimeFigureOut">
               <a:rPr lang="en-US" smtClean="0"/>
-              <a:t>4/6/26</a:t>
+              <a:t>4/13/26</a:t>
             </a:fld>
             <a:endParaRPr lang="en-US"/>
           </a:p>
@@ -9158,7 +9158,7 @@
           <a:p>
             <a:fld id="{B91EF44D-EE28-F64D-96D8-55EF481E7992}" type="datetimeFigureOut">
               <a:rPr lang="en-US" smtClean="0"/>
-              <a:t>4/6/26</a:t>
+              <a:t>4/13/26</a:t>
             </a:fld>
             <a:endParaRPr lang="en-US"/>
           </a:p>
@@ -9446,7 +9446,7 @@
           <a:p>
             <a:fld id="{B91EF44D-EE28-F64D-96D8-55EF481E7992}" type="datetimeFigureOut">
               <a:rPr lang="en-US" smtClean="0"/>
-              <a:t>4/6/26</a:t>
+              <a:t>4/13/26</a:t>
             </a:fld>
             <a:endParaRPr lang="en-US"/>
           </a:p>
@@ -9687,7 +9687,7 @@
           <a:p>
             <a:fld id="{B91EF44D-EE28-F64D-96D8-55EF481E7992}" type="datetimeFigureOut">
               <a:rPr lang="en-US" smtClean="0"/>
-              <a:t>4/6/26</a:t>
+              <a:t>4/13/26</a:t>
             </a:fld>
             <a:endParaRPr lang="en-US"/>
           </a:p>
@@ -18131,7 +18131,7 @@
             <p:ph idx="1"/>
             <p:extLst>
               <p:ext uri="{D42A27DB-BD31-4B8C-83A1-F6EECF244321}">
-                <p14:modId xmlns:p14="http://schemas.microsoft.com/office/powerpoint/2010/main" val="815416038"/>
+                <p14:modId xmlns:p14="http://schemas.microsoft.com/office/powerpoint/2010/main" val="3573825453"/>
               </p:ext>
             </p:extLst>
           </p:nvPr>
@@ -18302,8 +18302,8 @@
                     <a:lstStyle/>
                     <a:p>
                       <a:r>
-                        <a:rPr lang="en-US" sz="1800"/>
-                        <a:t>GPT 4.0</a:t>
+                        <a:rPr lang="en-US" sz="1800" dirty="0"/>
+                        <a:t>GPT 5</a:t>
                       </a:r>
                     </a:p>
                   </a:txBody>
@@ -18328,8 +18328,8 @@
                     <a:lstStyle/>
                     <a:p>
                       <a:r>
-                        <a:rPr lang="en-US" sz="1800"/>
-                        <a:t>89</a:t>
+                        <a:rPr lang="en-US" sz="1800" dirty="0"/>
+                        <a:t>79.6</a:t>
                       </a:r>
                     </a:p>
                   </a:txBody>
@@ -18341,8 +18341,8 @@
                     <a:lstStyle/>
                     <a:p>
                       <a:r>
-                        <a:rPr lang="en-US" sz="1800"/>
-                        <a:t>62</a:t>
+                        <a:rPr lang="en-US" sz="1800" dirty="0"/>
+                        <a:t>77.7</a:t>
                       </a:r>
                     </a:p>
                   </a:txBody>
@@ -18354,8 +18354,8 @@
                     <a:lstStyle/>
                     <a:p>
                       <a:r>
-                        <a:rPr lang="en-US" sz="1800"/>
-                        <a:t>67</a:t>
+                        <a:rPr lang="en-US" sz="1800" dirty="0"/>
+                        <a:t>78.0</a:t>
                       </a:r>
                     </a:p>
                   </a:txBody>
@@ -18366,7 +18366,10 @@
                     <a:bodyPr/>
                     <a:lstStyle/>
                     <a:p>
-                      <a:endParaRPr lang="en-US" sz="1800"/>
+                      <a:r>
+                        <a:rPr lang="en-US" sz="1800" dirty="0"/>
+                        <a:t>92.18min</a:t>
+                      </a:r>
                     </a:p>
                   </a:txBody>
                   <a:tcPr marL="89588" marR="89588" marT="44794" marB="44794"/>
@@ -18376,7 +18379,10 @@
                     <a:bodyPr/>
                     <a:lstStyle/>
                     <a:p>
-                      <a:endParaRPr lang="en-US" sz="1800"/>
+                      <a:r>
+                        <a:rPr lang="en-US" sz="1800" dirty="0"/>
+                        <a:t>4.26</a:t>
+                      </a:r>
                     </a:p>
                   </a:txBody>
                   <a:tcPr marL="89588" marR="89588" marT="44794" marB="44794"/>
@@ -18394,8 +18400,8 @@
                     <a:lstStyle/>
                     <a:p>
                       <a:r>
-                        <a:rPr lang="en-US" sz="1800"/>
-                        <a:t>GPT 4.0 </a:t>
+                        <a:rPr lang="en-US" sz="1800" dirty="0"/>
+                        <a:t>GPT 5</a:t>
                       </a:r>
                     </a:p>
                   </a:txBody>
@@ -18440,8 +18446,8 @@
                     <a:lstStyle/>
                     <a:p>
                       <a:r>
-                        <a:rPr lang="en-US" sz="1800"/>
-                        <a:t>90</a:t>
+                        <a:rPr lang="en-US" sz="1800" dirty="0"/>
+                        <a:t>82.8</a:t>
                       </a:r>
                     </a:p>
                   </a:txBody>
@@ -18453,8 +18459,8 @@
                     <a:lstStyle/>
                     <a:p>
                       <a:r>
-                        <a:rPr lang="en-US" sz="1800"/>
-                        <a:t>56</a:t>
+                        <a:rPr lang="en-US" sz="1800" dirty="0"/>
+                        <a:t>76.8</a:t>
                       </a:r>
                     </a:p>
                   </a:txBody>
@@ -18466,8 +18472,8 @@
                     <a:lstStyle/>
                     <a:p>
                       <a:r>
-                        <a:rPr lang="en-US" sz="1800"/>
-                        <a:t>63</a:t>
+                        <a:rPr lang="en-US" sz="1800" dirty="0"/>
+                        <a:t>78.0</a:t>
                       </a:r>
                     </a:p>
                   </a:txBody>
@@ -18478,7 +18484,10 @@
                     <a:bodyPr/>
                     <a:lstStyle/>
                     <a:p>
-                      <a:endParaRPr lang="en-US" sz="1800"/>
+                      <a:r>
+                        <a:rPr lang="en-US" sz="1800" dirty="0"/>
+                        <a:t>91.48min</a:t>
+                      </a:r>
                     </a:p>
                   </a:txBody>
                   <a:tcPr marL="89588" marR="89588" marT="44794" marB="44794"/>
@@ -18488,7 +18497,10 @@
                     <a:bodyPr/>
                     <a:lstStyle/>
                     <a:p>
-                      <a:endParaRPr lang="en-US" sz="1800" dirty="0"/>
+                      <a:r>
+                        <a:rPr lang="en-US" sz="1800" dirty="0"/>
+                        <a:t>4.12</a:t>
+                      </a:r>
                     </a:p>
                   </a:txBody>
                   <a:tcPr marL="89588" marR="89588" marT="44794" marB="44794"/>
@@ -21473,7 +21485,7 @@
           <p:nvPr>
             <p:extLst>
               <p:ext uri="{D42A27DB-BD31-4B8C-83A1-F6EECF244321}">
-                <p14:modId xmlns:p14="http://schemas.microsoft.com/office/powerpoint/2010/main" val="2469355933"/>
+                <p14:modId xmlns:p14="http://schemas.microsoft.com/office/powerpoint/2010/main" val="1927339695"/>
               </p:ext>
             </p:extLst>
           </p:nvPr>
@@ -21645,7 +21657,7 @@
                     <a:p>
                       <a:r>
                         <a:rPr lang="en-US" dirty="0"/>
-                        <a:t>GPT 4.0 </a:t>
+                        <a:t>GPT 5</a:t>
                       </a:r>
                     </a:p>
                   </a:txBody>
@@ -21671,7 +21683,7 @@
                     <a:p>
                       <a:r>
                         <a:rPr lang="en-US" dirty="0"/>
-                        <a:t>89</a:t>
+                        <a:t>80.6</a:t>
                       </a:r>
                     </a:p>
                   </a:txBody>
@@ -21684,7 +21696,7 @@
                     <a:p>
                       <a:r>
                         <a:rPr lang="en-US" dirty="0"/>
-                        <a:t>62</a:t>
+                        <a:t>79.1</a:t>
                       </a:r>
                     </a:p>
                   </a:txBody>
@@ -21697,7 +21709,7 @@
                     <a:p>
                       <a:r>
                         <a:rPr lang="en-US" dirty="0"/>
-                        <a:t>67</a:t>
+                        <a:t>79.3</a:t>
                       </a:r>
                     </a:p>
                   </a:txBody>
@@ -21708,7 +21720,10 @@
                     <a:bodyPr/>
                     <a:lstStyle/>
                     <a:p>
-                      <a:endParaRPr lang="en-US" dirty="0"/>
+                      <a:r>
+                        <a:rPr lang="en-US" dirty="0"/>
+                        <a:t>344.19min</a:t>
+                      </a:r>
                     </a:p>
                   </a:txBody>
                   <a:tcPr/>
@@ -21718,7 +21733,10 @@
                     <a:bodyPr/>
                     <a:lstStyle/>
                     <a:p>
-                      <a:endParaRPr lang="en-US" dirty="0"/>
+                      <a:r>
+                        <a:rPr lang="en-US" dirty="0"/>
+                        <a:t>17.29</a:t>
+                      </a:r>
                     </a:p>
                   </a:txBody>
                   <a:tcPr/>
@@ -21737,7 +21755,7 @@
                     <a:p>
                       <a:r>
                         <a:rPr lang="en-US" dirty="0"/>
-                        <a:t>GPT 4.0 </a:t>
+                        <a:t>GPT 5 </a:t>
                       </a:r>
                     </a:p>
                   </a:txBody>
@@ -21778,7 +21796,10 @@
                     <a:bodyPr/>
                     <a:lstStyle/>
                     <a:p>
-                      <a:endParaRPr lang="en-US"/>
+                      <a:r>
+                        <a:rPr lang="en-US" dirty="0"/>
+                        <a:t>81.5</a:t>
+                      </a:r>
                     </a:p>
                   </a:txBody>
                   <a:tcPr/>
@@ -21788,7 +21809,10 @@
                     <a:bodyPr/>
                     <a:lstStyle/>
                     <a:p>
-                      <a:endParaRPr lang="en-US"/>
+                      <a:r>
+                        <a:rPr lang="en-US" dirty="0"/>
+                        <a:t>79.8</a:t>
+                      </a:r>
                     </a:p>
                   </a:txBody>
                   <a:tcPr/>
@@ -21798,7 +21822,10 @@
                     <a:bodyPr/>
                     <a:lstStyle/>
                     <a:p>
-                      <a:endParaRPr lang="en-US"/>
+                      <a:r>
+                        <a:rPr lang="en-US" dirty="0"/>
+                        <a:t>80.0</a:t>
+                      </a:r>
                     </a:p>
                   </a:txBody>
                   <a:tcPr/>
@@ -21808,7 +21835,10 @@
                     <a:bodyPr/>
                     <a:lstStyle/>
                     <a:p>
-                      <a:endParaRPr lang="en-US"/>
+                      <a:r>
+                        <a:rPr lang="en-US" dirty="0"/>
+                        <a:t>361.59min</a:t>
+                      </a:r>
                     </a:p>
                   </a:txBody>
                   <a:tcPr/>
@@ -21818,7 +21848,10 @@
                     <a:bodyPr/>
                     <a:lstStyle/>
                     <a:p>
-                      <a:endParaRPr lang="en-US" dirty="0"/>
+                      <a:r>
+                        <a:rPr lang="en-US" dirty="0"/>
+                        <a:t>16.94</a:t>
+                      </a:r>
                     </a:p>
                   </a:txBody>
                   <a:tcPr/>

</xml_diff>